<commit_message>
Drop the dangling References entry from the table of contents
Co-Authored-By: Claude Sonnet 5 <noreply@anthropic.com>
Claude-Session: https://claude.ai/code/session_01QqTp2mZiFLzw61erVe3etE
</commit_message>
<xml_diff>
--- a/docs/KopaAlert-Project-Documentation.pptx
+++ b/docs/KopaAlert-Project-Documentation.pptx
@@ -13758,31 +13758,6 @@
                 <a:latin typeface="Calibri" panose="020F0502020204030204"/>
               </a:rPr>
               <a:t>•  18. Conclusion</a:t>
-            </a:r>
-            <a:endParaRPr sz="1700">
-              <a:solidFill>
-                <a:srgbClr val="121D21"/>
-              </a:solidFill>
-              <a:latin typeface="Calibri" panose="020F0502020204030204"/>
-            </a:endParaRPr>
-          </a:p>
-          <a:p>
-            <a:pPr>
-              <a:lnSpc>
-                <a:spcPct val="108000"/>
-              </a:lnSpc>
-              <a:spcAft>
-                <a:spcPts val="1600"/>
-              </a:spcAft>
-            </a:pPr>
-            <a:r>
-              <a:rPr sz="1700">
-                <a:solidFill>
-                  <a:srgbClr val="121D21"/>
-                </a:solidFill>
-                <a:latin typeface="Calibri" panose="020F0502020204030204"/>
-              </a:rPr>
-              <a:t>•  19. References</a:t>
             </a:r>
             <a:endParaRPr sz="1700">
               <a:solidFill>

</xml_diff>